<commit_message>
feat(cip,warehouse,wms): CIP module, dây chuyền identification, Xuất kho location gating
- Thêm module CIP (Danh mục, Khai báo, Lịch sử) đầy đủ: biểu mẫu, thiết bị, gắn CIP vào
  mẻ nấu/lô lên men/mẻ lọc/mã chiết, tiêu chuẩn khoá vs thực tế, in báo cáo spec-vs-actual.
- Thêm mã nhận dạng dây chuyền (ProductionLine.identification_code) + mã nhà máy
  (OpsSetting.factory_code) phục vụ truy xuất nguồn gốc ngoài thị trường.
- Sửa graph alembic 2 head (CIP + CA-value) bằng merge migration.
- Xuất kho (Kho TP): gate chọn xuất theo hàng đã cất vị trí, chỉ bật ô Cận date khi lô có
  hàng cận date thật, thêm cột Vị trí kho ở giỏ hàng, hiện "Từ kho" + cận date ở lịch sử.
- Mẫu in Biên bản bàn giao: chỉ in dòng có số lượng.
- Sắp xếp lại nút Khóa lô/Chỉ tiêu ở các bảng Nấu/Lên men/Lọc/Chiết cho dễ thao tác.

Co-Authored-By: Claude Sonnet 5 <noreply@anthropic.com>
</commit_message>
<xml_diff>
--- a/docs/MES-HuongDanSuDung.pptx
+++ b/docs/MES-HuongDanSuDung.pptx
@@ -3485,7 +3485,7 @@
                 </a:solidFill>
                 <a:latin typeface="Calibri"/>
               </a:rPr>
-              <a:t>Sách Hướng dẫn Sử dụng  ·  Phiên bản 0.1.0-mvp  ·  Tài liệu hướng dẫn nội bộ</a:t>
+              <a:t>Sách Hướng dẫn Sử dụng  ·  Phiên bản 0.1.0-mvp  ·  Cập nhật 25/07/2026</a:t>
             </a:r>
           </a:p>
         </p:txBody>
@@ -6949,7 +6949,7 @@
                 </a:solidFill>
                 <a:latin typeface="Calibri"/>
               </a:rPr>
-              <a:t>Đóng pallet, putaway, in tem</a:t>
+              <a:t>Nhập kho theo lô, cất vị trí, in tem</a:t>
             </a:r>
           </a:p>
         </p:txBody>

</xml_diff>